<commit_message>
Update : comment les trois parties communiquent
</commit_message>
<xml_diff>
--- a/SAÉ 3.02 – Présentation du projet.pptx
+++ b/SAÉ 3.02 – Présentation du projet.pptx
@@ -5,7 +5,7 @@
     <p:sldMasterId id="2147483648" r:id="rId1"/>
   </p:sldMasterIdLst>
   <p:notesMasterIdLst>
-    <p:notesMasterId r:id="rId9"/>
+    <p:notesMasterId r:id="rId8"/>
   </p:notesMasterIdLst>
   <p:sldIdLst>
     <p:sldId id="256" r:id="rId2"/>
@@ -14,7 +14,6 @@
     <p:sldId id="259" r:id="rId5"/>
     <p:sldId id="260" r:id="rId6"/>
     <p:sldId id="261" r:id="rId7"/>
-    <p:sldId id="262" r:id="rId8"/>
   </p:sldIdLst>
   <p:sldSz cx="12192000" cy="6858000"/>
   <p:notesSz cx="6858000" cy="12192000"/>
@@ -747,93 +746,6 @@
             <a:fld id="{F7021451-1387-4CA6-816F-3879F97B5CBC}" type="slidenum">
               <a:rPr lang="en-US"/>
               <a:t>6</a:t>
-            </a:fld>
-            <a:endParaRPr lang="en-US"/>
-          </a:p>
-        </p:txBody>
-      </p:sp>
-    </p:spTree>
-    <p:extLst>
-      <p:ext uri="{BB962C8B-B14F-4D97-AF65-F5344CB8AC3E}">
-        <p14:creationId xmlns:p14="http://schemas.microsoft.com/office/powerpoint/2010/main" val="1024086991"/>
-      </p:ext>
-    </p:extLst>
-  </p:cSld>
-  <p:clrMapOvr>
-    <a:masterClrMapping/>
-  </p:clrMapOvr>
-</p:notes>
-</file>
-
-<file path=ppt/notesSlides/notesSlide7.xml><?xml version="1.0" encoding="utf-8"?>
-<p:notes xmlns:a="http://schemas.openxmlformats.org/drawingml/2006/main" xmlns:r="http://schemas.openxmlformats.org/officeDocument/2006/relationships" xmlns:p="http://schemas.openxmlformats.org/presentationml/2006/main">
-  <p:cSld>
-    <p:spTree>
-      <p:nvGrpSpPr>
-        <p:cNvPr id="1" name=""/>
-        <p:cNvGrpSpPr/>
-        <p:nvPr/>
-      </p:nvGrpSpPr>
-      <p:grpSpPr>
-        <a:xfrm>
-          <a:off x="0" y="0"/>
-          <a:ext cx="0" cy="0"/>
-          <a:chOff x="0" y="0"/>
-          <a:chExt cx="0" cy="0"/>
-        </a:xfrm>
-      </p:grpSpPr>
-      <p:sp>
-        <p:nvSpPr>
-          <p:cNvPr id="2" name="Slide Image Placeholder 1"/>
-          <p:cNvSpPr>
-            <a:spLocks noGrp="1" noRot="1" noChangeAspect="1"/>
-          </p:cNvSpPr>
-          <p:nvPr>
-            <p:ph type="sldImg"/>
-          </p:nvPr>
-        </p:nvSpPr>
-        <p:spPr/>
-      </p:sp>
-      <p:sp>
-        <p:nvSpPr>
-          <p:cNvPr id="3" name="Notes Placeholder 2"/>
-          <p:cNvSpPr>
-            <a:spLocks noGrp="1"/>
-          </p:cNvSpPr>
-          <p:nvPr>
-            <p:ph type="body" idx="1"/>
-          </p:nvPr>
-        </p:nvSpPr>
-        <p:spPr/>
-        <p:txBody>
-          <a:bodyPr/>
-          <a:lstStyle/>
-          <a:p>
-            <a:r>
-              <a:rPr lang="en-US" dirty="0"/>
-              <a:t>Résumé de la matrice RACI : chaque membre pilote un domaine (base de données et intégration pour Anas, site web pour Adam, application Java pour Ainul), et l’analyse, les tests et la démonstration sont partagés. La matrice complète est dans le document Word rendu avec le projet.</a:t>
-            </a:r>
-          </a:p>
-        </p:txBody>
-      </p:sp>
-      <p:sp>
-        <p:nvSpPr>
-          <p:cNvPr id="4" name="Slide Number Placeholder 3"/>
-          <p:cNvSpPr>
-            <a:spLocks noGrp="1"/>
-          </p:cNvSpPr>
-          <p:nvPr>
-            <p:ph type="sldNum" sz="quarter" idx="10"/>
-          </p:nvPr>
-        </p:nvSpPr>
-        <p:spPr/>
-        <p:txBody>
-          <a:bodyPr/>
-          <a:lstStyle/>
-          <a:p>
-            <a:fld id="{F7021451-1387-4CA6-816F-3879F97B5CBC}" type="slidenum">
-              <a:rPr lang="en-US"/>
-              <a:t>7</a:t>
             </a:fld>
             <a:endParaRPr lang="en-US"/>
           </a:p>
@@ -2495,29 +2407,6 @@
       </p:pic>
       <p:pic>
         <p:nvPicPr>
-          <p:cNvPr id="5" name="Image 2" descr="connector"/>
-          <p:cNvPicPr>
-            <a:picLocks noChangeAspect="1"/>
-          </p:cNvPicPr>
-          <p:nvPr/>
-        </p:nvPicPr>
-        <p:blipFill>
-          <a:blip r:embed="rId4"/>
-          <a:srcRect/>
-          <a:stretch/>
-        </p:blipFill>
-        <p:spPr>
-          <a:xfrm>
-            <a:off x="2159000" y="2715261"/>
-            <a:ext cx="101600" cy="1562100"/>
-          </a:xfrm>
-          <a:prstGeom prst="rect">
-            <a:avLst/>
-          </a:prstGeom>
-        </p:spPr>
-      </p:pic>
-      <p:pic>
-        <p:nvPicPr>
           <p:cNvPr id="6" name="Image 3" descr="connector"/>
           <p:cNvPicPr>
             <a:picLocks noChangeAspect="1"/>
@@ -2525,7 +2414,7 @@
           <p:nvPr/>
         </p:nvPicPr>
         <p:blipFill>
-          <a:blip r:embed="rId5"/>
+          <a:blip r:embed="rId4"/>
           <a:srcRect/>
           <a:stretch/>
         </p:blipFill>
@@ -2886,13 +2775,13 @@
       </p:sp>
       <p:sp>
         <p:nvSpPr>
-          <p:cNvPr id="16" name="Shape 10"/>
-          <p:cNvSpPr/>
-          <p:nvPr/>
-        </p:nvSpPr>
-        <p:spPr>
-          <a:xfrm>
-            <a:off x="819150" y="4232911"/>
+          <p:cNvPr id="19" name="Shape 13"/>
+          <p:cNvSpPr/>
+          <p:nvPr/>
+        </p:nvSpPr>
+        <p:spPr>
+          <a:xfrm>
+            <a:off x="8591550" y="4232911"/>
             <a:ext cx="2781300" cy="1066800"/>
           </a:xfrm>
           <a:prstGeom prst="roundRect">
@@ -2913,121 +2802,6 @@
       </p:sp>
       <p:sp>
         <p:nvSpPr>
-          <p:cNvPr id="17" name="Text 11"/>
-          <p:cNvSpPr/>
-          <p:nvPr/>
-        </p:nvSpPr>
-        <p:spPr>
-          <a:xfrm>
-            <a:off x="839343" y="4503420"/>
-            <a:ext cx="2740914" cy="269240"/>
-          </a:xfrm>
-          <a:prstGeom prst="rect">
-            <a:avLst/>
-          </a:prstGeom>
-          <a:noFill/>
-          <a:ln/>
-        </p:spPr>
-        <p:txBody>
-          <a:bodyPr wrap="square" lIns="0" tIns="0" rIns="0" bIns="0" rtlCol="0" anchor="t">
-            <a:normAutofit/>
-          </a:bodyPr>
-          <a:lstStyle/>
-          <a:p>
-            <a:pPr marL="0" indent="0" algn="ctr">
-              <a:lnSpc>
-                <a:spcPts val="1920"/>
-              </a:lnSpc>
-              <a:buNone/>
-            </a:pPr>
-            <a:r>
-              <a:rPr lang="en-US" sz="1600" b="1" dirty="0">
-                <a:solidFill>
-                  <a:srgbClr val="0F1B2D"/>
-                </a:solidFill>
-                <a:latin typeface="IBM Plex Sans" pitchFamily="34" charset="0"/>
-                <a:ea typeface="IBM Plex Sans" pitchFamily="34" charset="-122"/>
-                <a:cs typeface="IBM Plex Sans" pitchFamily="34" charset="-120"/>
-              </a:rPr>
-              <a:t>Java des autres groupes</a:t>
-            </a:r>
-            <a:endParaRPr lang="en-US" sz="1600" dirty="0"/>
-          </a:p>
-        </p:txBody>
-      </p:sp>
-      <p:sp>
-        <p:nvSpPr>
-          <p:cNvPr id="18" name="Text 12"/>
-          <p:cNvSpPr/>
-          <p:nvPr/>
-        </p:nvSpPr>
-        <p:spPr>
-          <a:xfrm>
-            <a:off x="1159859" y="4798061"/>
-            <a:ext cx="2099882" cy="256540"/>
-          </a:xfrm>
-          <a:prstGeom prst="rect">
-            <a:avLst/>
-          </a:prstGeom>
-          <a:noFill/>
-          <a:ln/>
-        </p:spPr>
-        <p:txBody>
-          <a:bodyPr wrap="square" lIns="0" tIns="0" rIns="0" bIns="0" rtlCol="0" anchor="t">
-            <a:normAutofit/>
-          </a:bodyPr>
-          <a:lstStyle/>
-          <a:p>
-            <a:pPr marL="0" indent="0" algn="ctr">
-              <a:lnSpc>
-                <a:spcPts val="1820"/>
-              </a:lnSpc>
-              <a:buNone/>
-            </a:pPr>
-            <a:r>
-              <a:rPr lang="en-US" sz="1300" dirty="0">
-                <a:solidFill>
-                  <a:srgbClr val="3F4B5B"/>
-                </a:solidFill>
-                <a:latin typeface="IBM Plex Sans" pitchFamily="34" charset="0"/>
-                <a:ea typeface="IBM Plex Sans" pitchFamily="34" charset="-122"/>
-                <a:cs typeface="IBM Plex Sans" pitchFamily="34" charset="-120"/>
-              </a:rPr>
-              <a:t>Clients de notre /export</a:t>
-            </a:r>
-            <a:endParaRPr lang="en-US" sz="1300" dirty="0"/>
-          </a:p>
-        </p:txBody>
-      </p:sp>
-      <p:sp>
-        <p:nvSpPr>
-          <p:cNvPr id="19" name="Shape 13"/>
-          <p:cNvSpPr/>
-          <p:nvPr/>
-        </p:nvSpPr>
-        <p:spPr>
-          <a:xfrm>
-            <a:off x="8591550" y="4232911"/>
-            <a:ext cx="2781300" cy="1066800"/>
-          </a:xfrm>
-          <a:prstGeom prst="roundRect">
-            <a:avLst>
-              <a:gd name="adj" fmla="val 8929"/>
-            </a:avLst>
-          </a:prstGeom>
-          <a:solidFill>
-            <a:srgbClr val="ECE9DF"/>
-          </a:solidFill>
-          <a:ln w="12700">
-            <a:solidFill>
-              <a:srgbClr val="5C6670"/>
-            </a:solidFill>
-            <a:prstDash val="dash"/>
-          </a:ln>
-        </p:spPr>
-      </p:sp>
-      <p:sp>
-        <p:nvSpPr>
           <p:cNvPr id="20" name="Text 14"/>
           <p:cNvSpPr/>
           <p:nvPr/>
@@ -3323,50 +3097,6 @@
                 <a:cs typeface="IBM Plex Sans" pitchFamily="34" charset="-120"/>
               </a:rPr>
               <a:t>écrit</a:t>
-            </a:r>
-            <a:endParaRPr lang="en-US" sz="1200" dirty="0"/>
-          </a:p>
-        </p:txBody>
-      </p:sp>
-      <p:sp>
-        <p:nvSpPr>
-          <p:cNvPr id="27" name="Text 21"/>
-          <p:cNvSpPr/>
-          <p:nvPr/>
-        </p:nvSpPr>
-        <p:spPr>
-          <a:xfrm>
-            <a:off x="2311400" y="3388361"/>
-            <a:ext cx="2354580" cy="238760"/>
-          </a:xfrm>
-          <a:prstGeom prst="rect">
-            <a:avLst/>
-          </a:prstGeom>
-          <a:noFill/>
-          <a:ln/>
-        </p:spPr>
-        <p:txBody>
-          <a:bodyPr wrap="square" lIns="0" tIns="0" rIns="0" bIns="0" rtlCol="0" anchor="t">
-            <a:normAutofit/>
-          </a:bodyPr>
-          <a:lstStyle/>
-          <a:p>
-            <a:pPr marL="0" indent="0" algn="l">
-              <a:lnSpc>
-                <a:spcPts val="1680"/>
-              </a:lnSpc>
-              <a:buNone/>
-            </a:pPr>
-            <a:r>
-              <a:rPr lang="en-US" sz="1200" dirty="0">
-                <a:solidFill>
-                  <a:srgbClr val="3F4B5B"/>
-                </a:solidFill>
-                <a:latin typeface="IBM Plex Sans" pitchFamily="34" charset="0"/>
-                <a:ea typeface="IBM Plex Sans" pitchFamily="34" charset="-122"/>
-                <a:cs typeface="IBM Plex Sans" pitchFamily="34" charset="-120"/>
-              </a:rPr>
-              <a:t>publie le JSON sur /export</a:t>
             </a:r>
             <a:endParaRPr lang="en-US" sz="1200" dirty="0"/>
           </a:p>
@@ -6515,825 +6245,6 @@
                 <a:cs typeface="IBM Plex Sans" pitchFamily="34" charset="-120"/>
               </a:rPr>
               <a:t>6 / 7</a:t>
-            </a:r>
-            <a:endParaRPr lang="en-US" sz="1200" dirty="0"/>
-          </a:p>
-        </p:txBody>
-      </p:sp>
-    </p:spTree>
-  </p:cSld>
-  <p:clrMapOvr>
-    <a:masterClrMapping/>
-  </p:clrMapOvr>
-</p:sld>
-</file>
-
-<file path=ppt/slides/slide7.xml><?xml version="1.0" encoding="utf-8"?>
-<p:sld xmlns:a="http://schemas.openxmlformats.org/drawingml/2006/main" xmlns:r="http://schemas.openxmlformats.org/officeDocument/2006/relationships" xmlns:p="http://schemas.openxmlformats.org/presentationml/2006/main">
-  <p:cSld name="Slide 7">
-    <p:bg>
-      <p:bgPr>
-        <a:solidFill>
-          <a:srgbClr val="0F1B2D"/>
-        </a:solidFill>
-        <a:effectLst/>
-      </p:bgPr>
-    </p:bg>
-    <p:spTree>
-      <p:nvGrpSpPr>
-        <p:cNvPr id="1" name=""/>
-        <p:cNvGrpSpPr/>
-        <p:nvPr/>
-      </p:nvGrpSpPr>
-      <p:grpSpPr>
-        <a:xfrm>
-          <a:off x="0" y="0"/>
-          <a:ext cx="0" cy="0"/>
-          <a:chOff x="0" y="0"/>
-          <a:chExt cx="0" cy="0"/>
-        </a:xfrm>
-      </p:grpSpPr>
-      <p:sp>
-        <p:nvSpPr>
-          <p:cNvPr id="2" name="Text 0"/>
-          <p:cNvSpPr>
-            <a:spLocks noGrp="1"/>
-          </p:cNvSpPr>
-          <p:nvPr>
-            <p:ph type="title"/>
-          </p:nvPr>
-        </p:nvSpPr>
-        <p:spPr>
-          <a:xfrm>
-            <a:off x="812800" y="812800"/>
-            <a:ext cx="10883392" cy="492760"/>
-          </a:xfrm>
-          <a:prstGeom prst="rect">
-            <a:avLst/>
-          </a:prstGeom>
-          <a:noFill/>
-          <a:ln/>
-        </p:spPr>
-        <p:txBody>
-          <a:bodyPr wrap="square" lIns="0" tIns="0" rIns="0" bIns="0" rtlCol="0" anchor="t">
-            <a:normAutofit/>
-          </a:bodyPr>
-          <a:lstStyle/>
-          <a:p>
-            <a:pPr marL="0" indent="0" algn="l">
-              <a:lnSpc>
-                <a:spcPts val="3680"/>
-              </a:lnSpc>
-              <a:buNone/>
-            </a:pPr>
-            <a:r>
-              <a:rPr lang="en-US" sz="3200" b="1" i="0" dirty="0">
-                <a:solidFill>
-                  <a:srgbClr val="F6F5F0"/>
-                </a:solidFill>
-                <a:latin typeface="IBM Plex Sans" pitchFamily="34" charset="0"/>
-                <a:ea typeface="IBM Plex Sans" pitchFamily="34" charset="-122"/>
-                <a:cs typeface="IBM Plex Sans" pitchFamily="34" charset="-120"/>
-              </a:rPr>
-              <a:t>Qui fait quoi : la matrice RACI</a:t>
-            </a:r>
-            <a:endParaRPr lang="en-US" sz="3200" dirty="0"/>
-          </a:p>
-        </p:txBody>
-      </p:sp>
-      <p:sp>
-        <p:nvSpPr>
-          <p:cNvPr id="3" name="Shape 1"/>
-          <p:cNvSpPr/>
-          <p:nvPr/>
-        </p:nvSpPr>
-        <p:spPr>
-          <a:xfrm>
-            <a:off x="815975" y="1486536"/>
-            <a:ext cx="3380264" cy="2205990"/>
-          </a:xfrm>
-          <a:prstGeom prst="roundRect">
-            <a:avLst>
-              <a:gd name="adj" fmla="val 4462"/>
-            </a:avLst>
-          </a:prstGeom>
-          <a:solidFill>
-            <a:srgbClr val="16283F"/>
-          </a:solidFill>
-          <a:ln w="6350">
-            <a:solidFill>
-              <a:srgbClr val="28405E"/>
-            </a:solidFill>
-            <a:prstDash val="solid"/>
-          </a:ln>
-        </p:spPr>
-      </p:sp>
-      <p:sp>
-        <p:nvSpPr>
-          <p:cNvPr id="4" name="Text 2"/>
-          <p:cNvSpPr/>
-          <p:nvPr/>
-        </p:nvSpPr>
-        <p:spPr>
-          <a:xfrm>
-            <a:off x="1071880" y="1742439"/>
-            <a:ext cx="2954507" cy="360680"/>
-          </a:xfrm>
-          <a:prstGeom prst="rect">
-            <a:avLst/>
-          </a:prstGeom>
-          <a:noFill/>
-          <a:ln/>
-        </p:spPr>
-        <p:txBody>
-          <a:bodyPr wrap="square" lIns="0" tIns="0" rIns="0" bIns="0" rtlCol="0" anchor="t">
-            <a:normAutofit/>
-          </a:bodyPr>
-          <a:lstStyle/>
-          <a:p>
-            <a:pPr marL="0" indent="0" algn="l">
-              <a:lnSpc>
-                <a:spcPts val="2640"/>
-              </a:lnSpc>
-              <a:buNone/>
-            </a:pPr>
-            <a:r>
-              <a:rPr lang="en-US" sz="2200" b="1" dirty="0">
-                <a:solidFill>
-                  <a:srgbClr val="4FD6C4"/>
-                </a:solidFill>
-                <a:latin typeface="IBM Plex Sans" pitchFamily="34" charset="0"/>
-                <a:ea typeface="IBM Plex Sans" pitchFamily="34" charset="-122"/>
-                <a:cs typeface="IBM Plex Sans" pitchFamily="34" charset="-120"/>
-              </a:rPr>
-              <a:t>Anas</a:t>
-            </a:r>
-            <a:endParaRPr lang="en-US" sz="2200" dirty="0"/>
-          </a:p>
-        </p:txBody>
-      </p:sp>
-      <p:sp>
-        <p:nvSpPr>
-          <p:cNvPr id="5" name="Text 3"/>
-          <p:cNvSpPr/>
-          <p:nvPr/>
-        </p:nvSpPr>
-        <p:spPr>
-          <a:xfrm>
-            <a:off x="1071880" y="2179321"/>
-            <a:ext cx="2954507" cy="256540"/>
-          </a:xfrm>
-          <a:prstGeom prst="rect">
-            <a:avLst/>
-          </a:prstGeom>
-          <a:noFill/>
-          <a:ln/>
-        </p:spPr>
-        <p:txBody>
-          <a:bodyPr wrap="square" lIns="0" tIns="0" rIns="0" bIns="0" rtlCol="0" anchor="t">
-            <a:normAutofit/>
-          </a:bodyPr>
-          <a:lstStyle/>
-          <a:p>
-            <a:pPr marL="0" indent="0" algn="l">
-              <a:lnSpc>
-                <a:spcPts val="1820"/>
-              </a:lnSpc>
-              <a:buNone/>
-            </a:pPr>
-            <a:r>
-              <a:rPr lang="en-US" sz="1300" dirty="0">
-                <a:solidFill>
-                  <a:srgbClr val="B9C6D6"/>
-                </a:solidFill>
-                <a:latin typeface="IBM Plex Sans" pitchFamily="34" charset="0"/>
-                <a:ea typeface="IBM Plex Sans" pitchFamily="34" charset="-122"/>
-                <a:cs typeface="IBM Plex Sans" pitchFamily="34" charset="-120"/>
-              </a:rPr>
-              <a:t>Base de données, VM et intégration</a:t>
-            </a:r>
-            <a:endParaRPr lang="en-US" sz="1300" dirty="0"/>
-          </a:p>
-        </p:txBody>
-      </p:sp>
-      <p:sp>
-        <p:nvSpPr>
-          <p:cNvPr id="6" name="Text 4"/>
-          <p:cNvSpPr/>
-          <p:nvPr/>
-        </p:nvSpPr>
-        <p:spPr>
-          <a:xfrm>
-            <a:off x="1157224" y="2512061"/>
-            <a:ext cx="2861543" cy="718820"/>
-          </a:xfrm>
-          <a:prstGeom prst="rect">
-            <a:avLst/>
-          </a:prstGeom>
-          <a:noFill/>
-          <a:ln/>
-        </p:spPr>
-        <p:txBody>
-          <a:bodyPr wrap="square" lIns="0" tIns="0" rIns="0" bIns="0" rtlCol="0" anchor="t">
-            <a:normAutofit/>
-          </a:bodyPr>
-          <a:lstStyle/>
-          <a:p>
-            <a:pPr marL="168656" indent="-168656" algn="l">
-              <a:lnSpc>
-                <a:spcPts val="1820"/>
-              </a:lnSpc>
-              <a:buSzPct val="100000"/>
-              <a:buChar char="•"/>
-            </a:pPr>
-            <a:r>
-              <a:rPr lang="en-US" sz="1300" dirty="0">
-                <a:solidFill>
-                  <a:srgbClr val="F6F5F0"/>
-                </a:solidFill>
-                <a:latin typeface="IBM Plex Sans" pitchFamily="34" charset="0"/>
-                <a:ea typeface="IBM Plex Sans" pitchFamily="34" charset="-122"/>
-                <a:cs typeface="IBM Plex Sans" pitchFamily="34" charset="-120"/>
-              </a:rPr>
-              <a:t>SGBD, schéma, tables, tests</a:t>
-            </a:r>
-            <a:endParaRPr lang="en-US" sz="1300" dirty="0"/>
-          </a:p>
-          <a:p>
-            <a:pPr marL="168656" indent="-168656" algn="l">
-              <a:lnSpc>
-                <a:spcPts val="1820"/>
-              </a:lnSpc>
-              <a:buSzPct val="100000"/>
-              <a:buChar char="•"/>
-            </a:pPr>
-            <a:r>
-              <a:rPr lang="en-US" sz="1300" dirty="0">
-                <a:solidFill>
-                  <a:srgbClr val="F6F5F0"/>
-                </a:solidFill>
-                <a:latin typeface="IBM Plex Sans" pitchFamily="34" charset="0"/>
-                <a:ea typeface="IBM Plex Sans" pitchFamily="34" charset="-122"/>
-                <a:cs typeface="IBM Plex Sans" pitchFamily="34" charset="-120"/>
-              </a:rPr>
-              <a:t>Machine virtuelle</a:t>
-            </a:r>
-            <a:endParaRPr lang="en-US" sz="1300" dirty="0"/>
-          </a:p>
-          <a:p>
-            <a:pPr marL="168656" indent="-168656" algn="l">
-              <a:lnSpc>
-                <a:spcPts val="1820"/>
-              </a:lnSpc>
-              <a:buSzPct val="100000"/>
-              <a:buChar char="•"/>
-            </a:pPr>
-            <a:r>
-              <a:rPr lang="en-US" sz="1300" dirty="0">
-                <a:solidFill>
-                  <a:srgbClr val="F6F5F0"/>
-                </a:solidFill>
-                <a:latin typeface="IBM Plex Sans" pitchFamily="34" charset="0"/>
-                <a:ea typeface="IBM Plex Sans" pitchFamily="34" charset="-122"/>
-                <a:cs typeface="IBM Plex Sans" pitchFamily="34" charset="-120"/>
-              </a:rPr>
-              <a:t>Instructions d’installation</a:t>
-            </a:r>
-            <a:endParaRPr lang="en-US" sz="1300" dirty="0"/>
-          </a:p>
-        </p:txBody>
-      </p:sp>
-      <p:sp>
-        <p:nvSpPr>
-          <p:cNvPr id="7" name="Shape 5"/>
-          <p:cNvSpPr/>
-          <p:nvPr/>
-        </p:nvSpPr>
-        <p:spPr>
-          <a:xfrm>
-            <a:off x="4405789" y="1486536"/>
-            <a:ext cx="3380343" cy="2205990"/>
-          </a:xfrm>
-          <a:prstGeom prst="roundRect">
-            <a:avLst>
-              <a:gd name="adj" fmla="val 4462"/>
-            </a:avLst>
-          </a:prstGeom>
-          <a:solidFill>
-            <a:srgbClr val="16283F"/>
-          </a:solidFill>
-          <a:ln w="6350">
-            <a:solidFill>
-              <a:srgbClr val="28405E"/>
-            </a:solidFill>
-            <a:prstDash val="solid"/>
-          </a:ln>
-        </p:spPr>
-      </p:sp>
-      <p:sp>
-        <p:nvSpPr>
-          <p:cNvPr id="8" name="Text 6"/>
-          <p:cNvSpPr/>
-          <p:nvPr/>
-        </p:nvSpPr>
-        <p:spPr>
-          <a:xfrm>
-            <a:off x="4661694" y="1742439"/>
-            <a:ext cx="2954589" cy="360680"/>
-          </a:xfrm>
-          <a:prstGeom prst="rect">
-            <a:avLst/>
-          </a:prstGeom>
-          <a:noFill/>
-          <a:ln/>
-        </p:spPr>
-        <p:txBody>
-          <a:bodyPr wrap="square" lIns="0" tIns="0" rIns="0" bIns="0" rtlCol="0" anchor="t">
-            <a:normAutofit/>
-          </a:bodyPr>
-          <a:lstStyle/>
-          <a:p>
-            <a:pPr marL="0" indent="0" algn="l">
-              <a:lnSpc>
-                <a:spcPts val="2640"/>
-              </a:lnSpc>
-              <a:buNone/>
-            </a:pPr>
-            <a:r>
-              <a:rPr lang="en-US" sz="2200" b="1" dirty="0">
-                <a:solidFill>
-                  <a:srgbClr val="4FD6C4"/>
-                </a:solidFill>
-                <a:latin typeface="IBM Plex Sans" pitchFamily="34" charset="0"/>
-                <a:ea typeface="IBM Plex Sans" pitchFamily="34" charset="-122"/>
-                <a:cs typeface="IBM Plex Sans" pitchFamily="34" charset="-120"/>
-              </a:rPr>
-              <a:t>Adam</a:t>
-            </a:r>
-            <a:endParaRPr lang="en-US" sz="2200" dirty="0"/>
-          </a:p>
-        </p:txBody>
-      </p:sp>
-      <p:sp>
-        <p:nvSpPr>
-          <p:cNvPr id="9" name="Text 7"/>
-          <p:cNvSpPr/>
-          <p:nvPr/>
-        </p:nvSpPr>
-        <p:spPr>
-          <a:xfrm>
-            <a:off x="4661694" y="2179321"/>
-            <a:ext cx="2954589" cy="256540"/>
-          </a:xfrm>
-          <a:prstGeom prst="rect">
-            <a:avLst/>
-          </a:prstGeom>
-          <a:noFill/>
-          <a:ln/>
-        </p:spPr>
-        <p:txBody>
-          <a:bodyPr wrap="square" lIns="0" tIns="0" rIns="0" bIns="0" rtlCol="0" anchor="t">
-            <a:normAutofit/>
-          </a:bodyPr>
-          <a:lstStyle/>
-          <a:p>
-            <a:pPr marL="0" indent="0" algn="l">
-              <a:lnSpc>
-                <a:spcPts val="1820"/>
-              </a:lnSpc>
-              <a:buNone/>
-            </a:pPr>
-            <a:r>
-              <a:rPr lang="en-US" sz="1300" dirty="0">
-                <a:solidFill>
-                  <a:srgbClr val="B9C6D6"/>
-                </a:solidFill>
-                <a:latin typeface="IBM Plex Sans" pitchFamily="34" charset="0"/>
-                <a:ea typeface="IBM Plex Sans" pitchFamily="34" charset="-122"/>
-                <a:cs typeface="IBM Plex Sans" pitchFamily="34" charset="-120"/>
-              </a:rPr>
-              <a:t>Site web et dépôt GitHub</a:t>
-            </a:r>
-            <a:endParaRPr lang="en-US" sz="1300" dirty="0"/>
-          </a:p>
-        </p:txBody>
-      </p:sp>
-      <p:sp>
-        <p:nvSpPr>
-          <p:cNvPr id="10" name="Text 8"/>
-          <p:cNvSpPr/>
-          <p:nvPr/>
-        </p:nvSpPr>
-        <p:spPr>
-          <a:xfrm>
-            <a:off x="4747038" y="2512061"/>
-            <a:ext cx="2861625" cy="718820"/>
-          </a:xfrm>
-          <a:prstGeom prst="rect">
-            <a:avLst/>
-          </a:prstGeom>
-          <a:noFill/>
-          <a:ln/>
-        </p:spPr>
-        <p:txBody>
-          <a:bodyPr wrap="square" lIns="0" tIns="0" rIns="0" bIns="0" rtlCol="0" anchor="t">
-            <a:normAutofit/>
-          </a:bodyPr>
-          <a:lstStyle/>
-          <a:p>
-            <a:pPr marL="168656" indent="-168656" algn="l">
-              <a:lnSpc>
-                <a:spcPts val="1820"/>
-              </a:lnSpc>
-              <a:buSzPct val="100000"/>
-              <a:buChar char="•"/>
-            </a:pPr>
-            <a:r>
-              <a:rPr lang="en-US" sz="1300" dirty="0">
-                <a:solidFill>
-                  <a:srgbClr val="F6F5F0"/>
-                </a:solidFill>
-                <a:latin typeface="IBM Plex Sans" pitchFamily="34" charset="0"/>
-                <a:ea typeface="IBM Plex Sans" pitchFamily="34" charset="-122"/>
-                <a:cs typeface="IBM Plex Sans" pitchFamily="34" charset="-120"/>
-              </a:rPr>
-              <a:t>Maquette et interface du quizz</a:t>
-            </a:r>
-            <a:endParaRPr lang="en-US" sz="1300" dirty="0"/>
-          </a:p>
-          <a:p>
-            <a:pPr marL="168656" indent="-168656" algn="l">
-              <a:lnSpc>
-                <a:spcPts val="1820"/>
-              </a:lnSpc>
-              <a:buSzPct val="100000"/>
-              <a:buChar char="•"/>
-            </a:pPr>
-            <a:r>
-              <a:rPr lang="en-US" sz="1300" dirty="0">
-                <a:solidFill>
-                  <a:srgbClr val="F6F5F0"/>
-                </a:solidFill>
-                <a:latin typeface="IBM Plex Sans" pitchFamily="34" charset="0"/>
-                <a:ea typeface="IBM Plex Sans" pitchFamily="34" charset="-122"/>
-                <a:cs typeface="IBM Plex Sans" pitchFamily="34" charset="-120"/>
-              </a:rPr>
-              <a:t>Endpoint JSON /export</a:t>
-            </a:r>
-            <a:endParaRPr lang="en-US" sz="1300" dirty="0"/>
-          </a:p>
-          <a:p>
-            <a:pPr marL="168656" indent="-168656" algn="l">
-              <a:lnSpc>
-                <a:spcPts val="1820"/>
-              </a:lnSpc>
-              <a:buSzPct val="100000"/>
-              <a:buChar char="•"/>
-            </a:pPr>
-            <a:r>
-              <a:rPr lang="en-US" sz="1300" dirty="0">
-                <a:solidFill>
-                  <a:srgbClr val="F6F5F0"/>
-                </a:solidFill>
-                <a:latin typeface="IBM Plex Sans" pitchFamily="34" charset="0"/>
-                <a:ea typeface="IBM Plex Sans" pitchFamily="34" charset="-122"/>
-                <a:cs typeface="IBM Plex Sans" pitchFamily="34" charset="-120"/>
-              </a:rPr>
-              <a:t>Dépôt GitHub</a:t>
-            </a:r>
-            <a:endParaRPr lang="en-US" sz="1300" dirty="0"/>
-          </a:p>
-        </p:txBody>
-      </p:sp>
-      <p:sp>
-        <p:nvSpPr>
-          <p:cNvPr id="11" name="Shape 9"/>
-          <p:cNvSpPr/>
-          <p:nvPr/>
-        </p:nvSpPr>
-        <p:spPr>
-          <a:xfrm>
-            <a:off x="7995682" y="1486536"/>
-            <a:ext cx="3380343" cy="2205990"/>
-          </a:xfrm>
-          <a:prstGeom prst="roundRect">
-            <a:avLst>
-              <a:gd name="adj" fmla="val 4462"/>
-            </a:avLst>
-          </a:prstGeom>
-          <a:solidFill>
-            <a:srgbClr val="16283F"/>
-          </a:solidFill>
-          <a:ln w="6350">
-            <a:solidFill>
-              <a:srgbClr val="28405E"/>
-            </a:solidFill>
-            <a:prstDash val="solid"/>
-          </a:ln>
-        </p:spPr>
-      </p:sp>
-      <p:sp>
-        <p:nvSpPr>
-          <p:cNvPr id="12" name="Text 10"/>
-          <p:cNvSpPr/>
-          <p:nvPr/>
-        </p:nvSpPr>
-        <p:spPr>
-          <a:xfrm>
-            <a:off x="8251587" y="1742439"/>
-            <a:ext cx="2954589" cy="360680"/>
-          </a:xfrm>
-          <a:prstGeom prst="rect">
-            <a:avLst/>
-          </a:prstGeom>
-          <a:noFill/>
-          <a:ln/>
-        </p:spPr>
-        <p:txBody>
-          <a:bodyPr wrap="square" lIns="0" tIns="0" rIns="0" bIns="0" rtlCol="0" anchor="t">
-            <a:normAutofit/>
-          </a:bodyPr>
-          <a:lstStyle/>
-          <a:p>
-            <a:pPr marL="0" indent="0" algn="l">
-              <a:lnSpc>
-                <a:spcPts val="2640"/>
-              </a:lnSpc>
-              <a:buNone/>
-            </a:pPr>
-            <a:r>
-              <a:rPr lang="en-US" sz="2200" b="1" dirty="0">
-                <a:solidFill>
-                  <a:srgbClr val="4FD6C4"/>
-                </a:solidFill>
-                <a:latin typeface="IBM Plex Sans" pitchFamily="34" charset="0"/>
-                <a:ea typeface="IBM Plex Sans" pitchFamily="34" charset="-122"/>
-                <a:cs typeface="IBM Plex Sans" pitchFamily="34" charset="-120"/>
-              </a:rPr>
-              <a:t>Ainul</a:t>
-            </a:r>
-            <a:endParaRPr lang="en-US" sz="2200" dirty="0"/>
-          </a:p>
-        </p:txBody>
-      </p:sp>
-      <p:sp>
-        <p:nvSpPr>
-          <p:cNvPr id="13" name="Text 11"/>
-          <p:cNvSpPr/>
-          <p:nvPr/>
-        </p:nvSpPr>
-        <p:spPr>
-          <a:xfrm>
-            <a:off x="8251587" y="2179321"/>
-            <a:ext cx="2954589" cy="256540"/>
-          </a:xfrm>
-          <a:prstGeom prst="rect">
-            <a:avLst/>
-          </a:prstGeom>
-          <a:noFill/>
-          <a:ln/>
-        </p:spPr>
-        <p:txBody>
-          <a:bodyPr wrap="square" lIns="0" tIns="0" rIns="0" bIns="0" rtlCol="0" anchor="t">
-            <a:normAutofit/>
-          </a:bodyPr>
-          <a:lstStyle/>
-          <a:p>
-            <a:pPr marL="0" indent="0" algn="l">
-              <a:lnSpc>
-                <a:spcPts val="1820"/>
-              </a:lnSpc>
-              <a:buNone/>
-            </a:pPr>
-            <a:r>
-              <a:rPr lang="en-US" sz="1300" dirty="0">
-                <a:solidFill>
-                  <a:srgbClr val="B9C6D6"/>
-                </a:solidFill>
-                <a:latin typeface="IBM Plex Sans" pitchFamily="34" charset="0"/>
-                <a:ea typeface="IBM Plex Sans" pitchFamily="34" charset="-122"/>
-                <a:cs typeface="IBM Plex Sans" pitchFamily="34" charset="-120"/>
-              </a:rPr>
-              <a:t>Application Java</a:t>
-            </a:r>
-            <a:endParaRPr lang="en-US" sz="1300" dirty="0"/>
-          </a:p>
-        </p:txBody>
-      </p:sp>
-      <p:sp>
-        <p:nvSpPr>
-          <p:cNvPr id="14" name="Text 12"/>
-          <p:cNvSpPr/>
-          <p:nvPr/>
-        </p:nvSpPr>
-        <p:spPr>
-          <a:xfrm>
-            <a:off x="8336931" y="2512061"/>
-            <a:ext cx="2861625" cy="949960"/>
-          </a:xfrm>
-          <a:prstGeom prst="rect">
-            <a:avLst/>
-          </a:prstGeom>
-          <a:noFill/>
-          <a:ln/>
-        </p:spPr>
-        <p:txBody>
-          <a:bodyPr wrap="square" lIns="0" tIns="0" rIns="0" bIns="0" rtlCol="0" anchor="t">
-            <a:normAutofit/>
-          </a:bodyPr>
-          <a:lstStyle/>
-          <a:p>
-            <a:pPr marL="168656" indent="-168656" algn="l">
-              <a:lnSpc>
-                <a:spcPts val="1820"/>
-              </a:lnSpc>
-              <a:buSzPct val="100000"/>
-              <a:buChar char="•"/>
-            </a:pPr>
-            <a:r>
-              <a:rPr lang="en-US" sz="1300" dirty="0">
-                <a:solidFill>
-                  <a:srgbClr val="F6F5F0"/>
-                </a:solidFill>
-                <a:latin typeface="IBM Plex Sans" pitchFamily="34" charset="0"/>
-                <a:ea typeface="IBM Plex Sans" pitchFamily="34" charset="-122"/>
-                <a:cs typeface="IBM Plex Sans" pitchFamily="34" charset="-120"/>
-              </a:rPr>
-              <a:t>Classes, déroulement du quizz</a:t>
-            </a:r>
-            <a:endParaRPr lang="en-US" sz="1300" dirty="0"/>
-          </a:p>
-          <a:p>
-            <a:pPr marL="168656" indent="-168656" algn="l">
-              <a:lnSpc>
-                <a:spcPts val="1820"/>
-              </a:lnSpc>
-              <a:buSzPct val="100000"/>
-              <a:buChar char="•"/>
-            </a:pPr>
-            <a:r>
-              <a:rPr lang="en-US" sz="1300" dirty="0">
-                <a:solidFill>
-                  <a:srgbClr val="F6F5F0"/>
-                </a:solidFill>
-                <a:latin typeface="IBM Plex Sans" pitchFamily="34" charset="0"/>
-                <a:ea typeface="IBM Plex Sans" pitchFamily="34" charset="-122"/>
-                <a:cs typeface="IBM Plex Sans" pitchFamily="34" charset="-120"/>
-              </a:rPr>
-              <a:t>Import et export JSON</a:t>
-            </a:r>
-            <a:endParaRPr lang="en-US" sz="1300" dirty="0"/>
-          </a:p>
-          <a:p>
-            <a:pPr marL="168656" indent="-168656" algn="l">
-              <a:lnSpc>
-                <a:spcPts val="1820"/>
-              </a:lnSpc>
-              <a:buSzPct val="100000"/>
-              <a:buChar char="•"/>
-            </a:pPr>
-            <a:r>
-              <a:rPr lang="en-US" sz="1300" dirty="0">
-                <a:solidFill>
-                  <a:srgbClr val="F6F5F0"/>
-                </a:solidFill>
-                <a:latin typeface="IBM Plex Sans" pitchFamily="34" charset="0"/>
-                <a:ea typeface="IBM Plex Sans" pitchFamily="34" charset="-122"/>
-                <a:cs typeface="IBM Plex Sans" pitchFamily="34" charset="-120"/>
-              </a:rPr>
-              <a:t>Documentation des sources</a:t>
-            </a:r>
-            <a:endParaRPr lang="en-US" sz="1300" dirty="0"/>
-          </a:p>
-        </p:txBody>
-      </p:sp>
-      <p:sp>
-        <p:nvSpPr>
-          <p:cNvPr id="15" name="Text 13"/>
-          <p:cNvSpPr/>
-          <p:nvPr/>
-        </p:nvSpPr>
-        <p:spPr>
-          <a:xfrm>
-            <a:off x="812800" y="3898900"/>
-            <a:ext cx="10883392" cy="523240"/>
-          </a:xfrm>
-          <a:prstGeom prst="rect">
-            <a:avLst/>
-          </a:prstGeom>
-          <a:noFill/>
-          <a:ln/>
-        </p:spPr>
-        <p:txBody>
-          <a:bodyPr wrap="square" lIns="0" tIns="0" rIns="0" bIns="0" rtlCol="0" anchor="t">
-            <a:normAutofit/>
-          </a:bodyPr>
-          <a:lstStyle/>
-          <a:p>
-            <a:pPr marL="0" indent="0" algn="l">
-              <a:lnSpc>
-                <a:spcPts val="1960"/>
-              </a:lnSpc>
-              <a:buNone/>
-            </a:pPr>
-            <a:r>
-              <a:rPr lang="en-US" sz="1400" dirty="0">
-                <a:solidFill>
-                  <a:srgbClr val="B9C6D6"/>
-                </a:solidFill>
-                <a:latin typeface="IBM Plex Sans" pitchFamily="34" charset="0"/>
-                <a:ea typeface="IBM Plex Sans" pitchFamily="34" charset="-122"/>
-                <a:cs typeface="IBM Plex Sans" pitchFamily="34" charset="-120"/>
-              </a:rPr>
-              <a:t>Tout le groupe : analyse du sujet, tests, correction des bugs et démonstration. Chacun rédige son propre rapport sur l’utilisation de l’IA.</a:t>
-            </a:r>
-            <a:endParaRPr lang="en-US" sz="1400" dirty="0"/>
-          </a:p>
-        </p:txBody>
-      </p:sp>
-      <p:sp>
-        <p:nvSpPr>
-          <p:cNvPr id="16" name="Text 14"/>
-          <p:cNvSpPr/>
-          <p:nvPr/>
-        </p:nvSpPr>
-        <p:spPr>
-          <a:xfrm>
-            <a:off x="812800" y="6238239"/>
-            <a:ext cx="4898994" cy="238760"/>
-          </a:xfrm>
-          <a:prstGeom prst="rect">
-            <a:avLst/>
-          </a:prstGeom>
-          <a:noFill/>
-          <a:ln/>
-        </p:spPr>
-        <p:txBody>
-          <a:bodyPr wrap="square" lIns="0" tIns="0" rIns="0" bIns="0" rtlCol="0" anchor="t">
-            <a:normAutofit/>
-          </a:bodyPr>
-          <a:lstStyle/>
-          <a:p>
-            <a:pPr marL="0" indent="0" algn="l">
-              <a:lnSpc>
-                <a:spcPts val="1680"/>
-              </a:lnSpc>
-              <a:buNone/>
-            </a:pPr>
-            <a:r>
-              <a:rPr lang="en-US" sz="1200" dirty="0">
-                <a:solidFill>
-                  <a:srgbClr val="8FA1B7"/>
-                </a:solidFill>
-                <a:latin typeface="IBM Plex Sans" pitchFamily="34" charset="0"/>
-                <a:ea typeface="IBM Plex Sans" pitchFamily="34" charset="-122"/>
-                <a:cs typeface="IBM Plex Sans" pitchFamily="34" charset="-120"/>
-              </a:rPr>
-              <a:t>SAÉ 3.02 · Quizz d’hygiène informatique et de cybersécurité</a:t>
-            </a:r>
-            <a:endParaRPr lang="en-US" sz="1200" dirty="0"/>
-          </a:p>
-        </p:txBody>
-      </p:sp>
-      <p:sp>
-        <p:nvSpPr>
-          <p:cNvPr id="17" name="Text 15"/>
-          <p:cNvSpPr/>
-          <p:nvPr/>
-        </p:nvSpPr>
-        <p:spPr>
-          <a:xfrm>
-            <a:off x="11003344" y="6238239"/>
-            <a:ext cx="375857" cy="238760"/>
-          </a:xfrm>
-          <a:prstGeom prst="rect">
-            <a:avLst/>
-          </a:prstGeom>
-          <a:noFill/>
-          <a:ln/>
-        </p:spPr>
-        <p:txBody>
-          <a:bodyPr wrap="square" lIns="0" tIns="0" rIns="0" bIns="0" rtlCol="0" anchor="t">
-            <a:normAutofit/>
-          </a:bodyPr>
-          <a:lstStyle/>
-          <a:p>
-            <a:pPr marL="0" indent="0" algn="r">
-              <a:lnSpc>
-                <a:spcPts val="1680"/>
-              </a:lnSpc>
-              <a:buNone/>
-            </a:pPr>
-            <a:r>
-              <a:rPr lang="en-US" sz="1200" dirty="0">
-                <a:solidFill>
-                  <a:srgbClr val="8FA1B7"/>
-                </a:solidFill>
-                <a:latin typeface="IBM Plex Sans" pitchFamily="34" charset="0"/>
-                <a:ea typeface="IBM Plex Sans" pitchFamily="34" charset="-122"/>
-                <a:cs typeface="IBM Plex Sans" pitchFamily="34" charset="-120"/>
-              </a:rPr>
-              <a:t>7 / 7</a:t>
             </a:r>
             <a:endParaRPr lang="en-US" sz="1200" dirty="0"/>
           </a:p>

</xml_diff>